<commit_message>
Fill founder name in investor materials
Replace the {{اسم المؤسس}} placeholder with the founder's name
(عادل يحي احمد مدخلي) across the pitch page, deck, and feasibility
study, and note that Captain Adel is named after him.

Co-Authored-By: Claude Opus 4.8 <noreply@anthropic.com>
Claude-Session: https://claude.ai/code/session_01UqxyXCKAZWDhSN6Jr5o9ix
</commit_message>
<xml_diff>
--- a/docs/investor/fly-gaca-pitch-ar.pptx
+++ b/docs/investor/fly-gaca-pitch-ar.pptx
@@ -5681,7 +5681,7 @@
                 <a:ea typeface="Arial" pitchFamily="34" charset="-122"/>
                 <a:cs typeface="Arial" pitchFamily="34" charset="-120"/>
               </a:rPr>
-              <a:t>{{اسم المؤسس}} — المؤسس والمطوّر</a:t>
+              <a:t>عادل يحي احمد مدخلي — المؤسس والمطوّر</a:t>
             </a:r>
             <a:endParaRPr lang="ar-SA" sz="2000" dirty="0"/>
           </a:p>
@@ -5695,7 +5695,7 @@
         </p:nvSpPr>
         <p:spPr>
           <a:xfrm>
-            <a:off x="914400" y="3520440"/>
+            <a:off x="914400" y="3566160"/>
             <a:ext cx="8869680" cy="1005840"/>
           </a:xfrm>
           <a:prstGeom prst="rect">
@@ -5720,7 +5720,7 @@
                 <a:ea typeface="Arial" pitchFamily="34" charset="-122"/>
                 <a:cs typeface="Arial" pitchFamily="34" charset="-120"/>
               </a:rPr>
-              <a:t>صاحب الفكرة والمطوّر الذي بنى المنصّة كاملة — الواجهة، الخلفية، والكوربوس التنظيمي — وبرمج مساعد كابتن عادل (RAG) بنفسه. منتج حيّ متكامل أنجزه مؤسس واحد: دليل قدرة تنفيذ ورأس مال بشري فعّال.</a:t>
+              <a:t>صاحب الفكرة والمطوّر الذي بنى المنصّة كاملة — الواجهة، الخلفية، والكوربوس التنظيمي — وبرمج مساعد كابتن عادل (RAG) بنفسه (المساعد يحمل اسمه). منتج حيّ متكامل أنجزه مؤسس واحد: دليل قدرة تنفيذ ورأس مال بشري فعّال.</a:t>
             </a:r>
             <a:endParaRPr lang="ar-SA" sz="1400" dirty="0"/>
           </a:p>
@@ -5729,45 +5729,6 @@
       <p:sp>
         <p:nvSpPr>
           <p:cNvPr id="9" name="Text 7"/>
-          <p:cNvSpPr/>
-          <p:nvPr/>
-        </p:nvSpPr>
-        <p:spPr>
-          <a:xfrm>
-            <a:off x="914400" y="4480560"/>
-            <a:ext cx="8869680" cy="320040"/>
-          </a:xfrm>
-          <a:prstGeom prst="rect">
-            <a:avLst/>
-          </a:prstGeom>
-          <a:noFill/>
-          <a:ln/>
-        </p:spPr>
-        <p:txBody>
-          <a:bodyPr wrap="square" rtlCol="0" anchor="ctr"/>
-          <a:lstStyle/>
-          <a:p>
-            <a:pPr rtl="1" algn="r" indent="0" marL="0">
-              <a:buNone/>
-            </a:pPr>
-            <a:r>
-              <a:rPr lang="ar-SA" altLang="en-US" sz="1050" dirty="0">
-                <a:solidFill>
-                  <a:srgbClr val="8A95A1"/>
-                </a:solidFill>
-                <a:latin typeface="Arial" pitchFamily="34" charset="0"/>
-                <a:ea typeface="Arial" pitchFamily="34" charset="-122"/>
-                <a:cs typeface="Arial" pitchFamily="34" charset="-120"/>
-              </a:rPr>
-              <a:t>* الاسم والسيرة placeholder — يملؤها المؤسس قبل الإرسال للمستثمر.</a:t>
-            </a:r>
-            <a:endParaRPr lang="ar-SA" sz="1050" dirty="0"/>
-          </a:p>
-        </p:txBody>
-      </p:sp>
-      <p:sp>
-        <p:nvSpPr>
-          <p:cNvPr id="10" name="Text 8"/>
           <p:cNvSpPr/>
           <p:nvPr/>
         </p:nvSpPr>
@@ -5806,7 +5767,7 @@
       </p:sp>
       <p:sp>
         <p:nvSpPr>
-          <p:cNvPr id="11" name="Text 9"/>
+          <p:cNvPr id="10" name="Text 8"/>
           <p:cNvSpPr/>
           <p:nvPr/>
         </p:nvSpPr>
@@ -5845,7 +5806,7 @@
       </p:sp>
       <p:sp>
         <p:nvSpPr>
-          <p:cNvPr id="12" name="Text 10"/>
+          <p:cNvPr id="11" name="Text 9"/>
           <p:cNvSpPr/>
           <p:nvPr/>
         </p:nvSpPr>

</xml_diff>